<commit_message>
docs: streamline Scene 3 video script and presentation notes with README proof reference
</commit_message>
<xml_diff>
--- a/presentation.pptx
+++ b/presentation.pptx
@@ -507,7 +507,23 @@
           <a:lstStyle/>
           <a:p>
             <a:r>
-              <a:t>[0:00 - 0:25] Welcome judges. This is GridWise, our solution for the BUP CSE Fest 2026 Smart Campus Energy Optimization Challenge. Universities manage rooftop solar, dynamic tariffs, and battery storage, while facility managers provide unstructured constraints. GridWise bridges natural language directives with mathematically provable linear optimization.</a:t>
+              <a:t>=== বাংলা স্ক্রিপ্ট (BANGLA) [0:00 - 0:25] ===</a:t>
+            </a:r>
+          </a:p>
+          <a:p>
+            <a:r>
+              <a:t>সম্মানিত বিচারকমণ্ডলী, সবাইকে স্বাগত জানাচ্ছি আমাদের প্রজেক্ট GridWise-এ — BUP CSE Fest 2026 স্মার্ট ক্যাম্পাস এনার্জি অপটিমাইজেশন চ্যালেঞ্জের জন্য আমাদের সমাধান। একটি আধুনিক বিশ্ববিদ্যালয় ক্যাম্পাসে ওঠানামা করা রুফটপ সোলার জেনারেশন, ক্যাম্পাসের জটিল ইলেকট্রিক্যাল ডিমান্ড এবং পরিবর্তনশীল গ্রিড ট্যারিফের ভারসাম্য রক্ষা করা অত্যন্ত জটিল। এর ওপর ফ্যাসিলিটি ম্যানেজাররা বিভিন্ন অপারেশনাল নির্দেশনা দেন সাধারণ ভাষায়। আমাদের মিশন: এই প্রাকৃতিক ভাষার নির্দেশনাগুলোকে নির্ভুল গাণিতিক কনস্ট্রেইন্টে রূপান্তর করে ২৪ ঘণ্টার এমন একটি ব্যাটারি শিডিউল তৈরি করা, যা বিদ্যুৎ খরচ সর্বনিম্ন রাখবে এবং ক্যাম্পাসের কোনো ফিজিক্যাল নিয়ম ভঙ্গ করবে না।</a:t>
+            </a:r>
+          </a:p>
+          <a:p/>
+          <a:p>
+            <a:r>
+              <a:t>=== ENGLISH SCRIPT [0:00 - 0:25] ===</a:t>
+            </a:r>
+          </a:p>
+          <a:p>
+            <a:r>
+              <a:t>Welcome judges. This is GridWise, our solution for the BUP CSE Fest 2026 Smart Campus Energy Optimization Challenge. Universities manage fluctuating rooftop solar, dynamic tariffs, and battery storage, while facility managers provide unstructured constraints. GridWise bridges natural language directives with mathematically provable linear optimization.</a:t>
             </a:r>
           </a:p>
         </p:txBody>
@@ -577,7 +593,23 @@
           <a:lstStyle/>
           <a:p>
             <a:r>
-              <a:t>[0:25 - 0:55] Our core design philosophy: never trust generative AI with raw microgrid math. We built a decoupled 4-stage pipeline. Stage 1 validates schemas. Stage 2 uses DeepSeek or Groq for semantic extraction, backed by an offline regex engine. Stage 3 normalizes constraints deterministically. Stage 4 executes continuous linear programming in SciPy HiGHS, validated by an independent physics replay.</a:t>
+              <a:t>=== বাংলা স্ক্রিপ্ট (BANGLA) [0:25 - 0:55] ===</a:t>
+            </a:r>
+          </a:p>
+          <a:p>
+            <a:r>
+              <a:t>আমাদের সিস্টেম আর্কিটেকচারের মূল দর্শন একটাই: কখনোই জেনারেটিভ এআই-এর ওপর র (raw) মাইক্রোগ্রিড ম্যাথ বা সমীকরণ সমাধানের দায়িত্ব ছেড়ে দেওয়া যাবে না। এজন্য আমরা তৈরি করেছি একটি ডিকাপল্ড চার স্টেজের পাইপলাইন: প্রথমত, আমাদের LLM ডিরেক্টিভ ইন্টারপ্রেটার DeepSeek-V3, Groq কিংবা OpenAI ব্যবহার করে জিরো-শট প্রম্পটিংয়ের মাধ্যমে অপারেটরের নোট থেকে আসল ইনটেন্ট বের করে আনে এবং অপ্রাসঙ্গিক মন্তব্য সম্পূর্ণ উপেক্ষা করে। দ্বিতীয়ত, যদি কোনো কারণে এক্সটার্নাল এআই সার্ভিসে নেটওয়ার্ক লেটেন্সি বা এপিআই ফেইলিওর দেখা দেয়, আমাদের সিস্টেমে থাকা অফলাইন ডিটারমিনিস্টিক রেজেক্স পার্সার স্বয়ংক্রিয়ভাবে ব্যাকআপ নেয় — যা নিশ্চিত করে ১০০% সিস্টেম আপটাইম এবং জিরো ডাউনটাইম।</a:t>
+            </a:r>
+          </a:p>
+          <a:p/>
+          <a:p>
+            <a:r>
+              <a:t>=== ENGLISH SCRIPT [0:25 - 0:55] ===</a:t>
+            </a:r>
+          </a:p>
+          <a:p>
+            <a:r>
+              <a:t>Our core design philosophy: never trust generative AI with raw microgrid math. We built a decoupled 4-stage pipeline. Stage 1 validates schemas. Stage 2 uses DeepSeek or Groq for semantic extraction, backed by an offline regex engine. Stage 3 normalizes constraints deterministically. Stage 4 executes continuous linear programming in SciPy HiGHS, validated by an independent physics replay.</a:t>
             </a:r>
           </a:p>
         </p:txBody>
@@ -647,7 +679,23 @@
           <a:lstStyle/>
           <a:p>
             <a:r>
-              <a:t>[0:55 - 1:35] Before reaching the LP solver, every directive must pass our guardrail layer. We enforce the invariant that applies is false if and only if directive_type is no_op. We hardened the system against real-world adversarial attacks: disambiguating 'reduced by' vs 'reduced to', handling noon-crossing intervals, and preventing substring collisions. Our 91-test adversarial suite verifies zero crashes and complete secret protection.</a:t>
+              <a:t>=== বাংলা স্ক্রিপ্ট (BANGLA) [0:55 - 1:35] ===</a:t>
+            </a:r>
+          </a:p>
+          <a:p>
+            <a:r>
+              <a:t>সলভারে পৌঁছানোর আগে প্রতিটি ডিরেক্টিভকে পার হতে হয় আমাদের ডিটারমিনিস্টিক গার্ডরেইল লেয়ার। এই লেয়ারটি নিশ্চিত করে মূল গাণিতিক নীতি: applies মান false হবে কেবল এবং কেবল যদি ডিরেক্টিভটি একটি no_op হয়। আমরা বাস্তব জীবনের নানা জটিল অ্যাডভারসারিয়াল এজ-কেস সমাধান করেছি: 'reduced by 80%' এবং 'reduced to 20%' উভয়কেই ফ্যাক্টর ০.২০-এ রূপান্তর করা, দুপুর ১২টা বা মধ্যরাত অতিক্রম করা টাইম উইন্ডো নরমালাইজ করা, ব্যাটারি চার্জিং ও ডিসচার্জিংয়ের সাবস্ট্রিং কনফ্লিক্ট সমাধান করা, এবং NaN ও ইনফিনিটির মতো ক্ষতিকর ইনপুট ফিল্টার করা। আমাদের ৯১টি টেস্ট ভেক্টরের অ্যাডভারসারিয়াল টেস্ট স্যুটে প্রতিটি এজ-কেস সফলভাবে পাস করেছে।</a:t>
+            </a:r>
+          </a:p>
+          <a:p/>
+          <a:p>
+            <a:r>
+              <a:t>=== ENGLISH SCRIPT [0:55 - 1:35] ===</a:t>
+            </a:r>
+          </a:p>
+          <a:p>
+            <a:r>
+              <a:t>Before reaching the LP solver, every directive must pass our guardrail layer. We enforce the invariant that applies is false if and only if directive_type is no_op. We hardened the system against real-world adversarial attacks: disambiguating 'reduced by' vs 'reduced to', handling noon-crossing intervals, and preventing substring collisions. Our 91-test adversarial suite verifies zero crashes and complete secret protection.</a:t>
             </a:r>
           </a:p>
         </p:txBody>
@@ -717,7 +765,23 @@
           <a:lstStyle/>
           <a:p>
             <a:r>
-              <a:t>[1:35 - 2:15] At the core is our optimization engine, formulated as a continuous Linear Program with 96 decision variables and 73 constraints. Solved using SciPy's HiGHS solver, it guarantees the global mathematical minimum cost in under 5 milliseconds. Crucially, it enforces end-of-day battery neutrality, ensuring starting energy equals ending energy.</a:t>
+              <a:t>=== বাংলা স্ক্রিপ্ট (BANGLA) [1:35 - 2:15] ===</a:t>
+            </a:r>
+          </a:p>
+          <a:p>
+            <a:r>
+              <a:t>এবার আসা যাক আমাদের অপটিমাইজেশন ফর্মুলেশনে: আমরা মাইক্রোগ্রিডের ২৪ ঘণ্টার এনার্জি শিডিউলিংকে ৯৬টি ডিসিশন ভেরিয়েবল এবং ৭৩টি ফিজিক্যাল কনস্ট্রেইন্ট দিয়ে একটি কনটিনিউয়াস লিনিয়ার প্রোগ্রাম হিসেবে মডেল করেছি। ব্যাটারির ডাইনামিক্স আনরোল করে ক্যাপাসিটি ও ডায়নামিক রিজার্ভ ফ্লোর নির্ধারণ করা হয়েছে এবং কঠোরভাবে নিশ্চিত করা হয়েছে এন্ড-অফ-ডে ব্যাটারি নিউট্রালিটি (E24 = E0)। পুরো সিস্টেমটি SciPy-এর HiGHS সিমপ্লেক্স সলভার দিয়ে মাত্র ৫ মিলি-সেকেন্ডের কম সময়ে সমাধান করা হয়, যা গাণিতিকভাবে সর্বনিম্ন খরচ নিশ্চিত করে। এই ফর্মুলেশনের সম্পূর্ণ গাণিতিক ডেরিভেশন এবং গ্লোবাল অপটিমালিটির বিশদ প্রমাণ আমাদের রিপোজিটরির README-এর সেকশন ৩-এ বিস্তারিতভাবে উল্লেখ করা আছে।</a:t>
+            </a:r>
+          </a:p>
+          <a:p/>
+          <a:p>
+            <a:r>
+              <a:t>=== ENGLISH SCRIPT [1:35 - 2:15] ===</a:t>
+            </a:r>
+          </a:p>
+          <a:p>
+            <a:r>
+              <a:t>At the core is our optimization engine: we formulated the 24-hour campus microgrid as a continuous Linear Program with 96 decision variables and 73 physical constraints. Solved using SciPy's HiGHS solver in under 5 milliseconds, it guarantees the mathematically global minimum cost. Crucially, it enforces end-of-day battery neutrality (E24 = E0). The complete step-by-step mathematical derivation and analytical proof of global optimality are documented in Section 3 of our README.</a:t>
             </a:r>
           </a:p>
         </p:txBody>
@@ -787,7 +851,23 @@
           <a:lstStyle/>
           <a:p>
             <a:r>
-              <a:t>[2:15 - 2:45] Here is the live verification against the 10 official reference samples. GridWise achieved 100% directive extraction precision and exactly 0.0000 BDT cost difference across all test cases. In addition, our 91 adversarial tests pass with zero exceptions.</a:t>
+              <a:t>=== বাংলা স্ক্রিপ্ট (BANGLA) [2:15 - 2:45] ===</a:t>
+            </a:r>
+          </a:p>
+          <a:p>
+            <a:r>
+              <a:t>এবার সরাসরি আমাদের সিস্টেমের ভেরিফিকেশন দেখে নেওয়া যাক। অফিসিয়াল ১০টি রেফারেন্স স্যাম্পল কেসের ওপর টেস্ট চালিয়ে আমরা দেখতে পাচ্ছি: প্রতিটি অপারেটর ডিরেক্টিভ ১০০% প্রিসিশন নিয়ে এক্সট্র্যাক্ট হয়েছে। সলভার প্রতিটি ফিজিক্যাল কনস্ট্রেইন্ট সফলভাবে বজায় রেখেছে, এবং আমাদের অপটিমাইজারের মোট খরচ অফিসিয়াল রেফারেন্স ফলাফলের সাথে প্রতিটি কেসেই ঠিক ০.০০০০ টাকা (0.0000 BDT) পার্থক্যে নিখুঁতভাবে মিলে গেছে! পাশাপাশি, pytest tests/test_adversarial.py রান করলে আমাদের ৯১টি টেস্টের সবকটিই গ্রিন পাস দেখায়, যা প্রমাণ করে সিস্টেমের অটুট নির্ভুলতা।</a:t>
+            </a:r>
+          </a:p>
+          <a:p/>
+          <a:p>
+            <a:r>
+              <a:t>=== ENGLISH SCRIPT [2:15 - 2:45] ===</a:t>
+            </a:r>
+          </a:p>
+          <a:p>
+            <a:r>
+              <a:t>Here is the live verification against the 10 official reference samples. GridWise achieved 100% directive extraction precision and exactly 0.0000 BDT cost difference across all test cases. In addition, our 91 adversarial tests pass with zero exceptions.</a:t>
             </a:r>
           </a:p>
         </p:txBody>
@@ -857,7 +937,23 @@
           <a:lstStyle/>
           <a:p>
             <a:r>
-              <a:t>[2:45 - 3:00] In conclusion, GridWise is fully production-ready, passing every single pre-submit criterion with a live cloud API, GHCR Docker container, and 100% benchmark accuracy. Thank you to the BUP CSE Fest committee and Poridhi.io!</a:t>
+              <a:t>=== বাংলা স্ক্রিপ্ট (BANGLA) [2:45 - 3:00] ===</a:t>
+            </a:r>
+          </a:p>
+          <a:p>
+            <a:r>
+              <a:t>GridWise সম্পূর্ণ প্রোডাকশন-রেডি। এটি লাইভ ক্লাউডে ডেপ্লয় করা হয়েছে, রয়েছে গিটহাব প্যাকেজে নন-রুট মাল্টি-স্টেজ ডকার কন্টেইনার এবং কোডবেসে কোনো হার্ডকোডেড ক্রেডেনশিয়াল নেই। পেজ ১১-এর প্রি-সাবমিট চেকলিস্টের ১০টি আইটেমই সম্পূর্ণ সবুজ। বুদ্ধিদীপ্ত ভাষা অনুধাবন এবং নিখুঁত গাণিতিক অপটিমাইজেশনের মেলবন্ধনই হলো GridWise। ধন্যবাদ BUP CSE Fest এবং Poridhi.io-কে!</a:t>
+            </a:r>
+          </a:p>
+          <a:p/>
+          <a:p>
+            <a:r>
+              <a:t>=== ENGLISH SCRIPT [2:45 - 3:00] ===</a:t>
+            </a:r>
+          </a:p>
+          <a:p>
+            <a:r>
+              <a:t>In conclusion, GridWise is fully production-ready, passing every single pre-submit criterion with a live cloud API, GHCR Docker container, and 100% benchmark accuracy. Thank you to the BUP CSE Fest committee and Poridhi.io!</a:t>
             </a:r>
           </a:p>
         </p:txBody>
@@ -3878,7 +3974,7 @@
             <a:avLst/>
           </a:prstGeom>
           <a:solidFill>
-            <a:srgbClr val="0F172A"/>
+            <a:srgbClr val="070A12"/>
           </a:solidFill>
           <a:ln>
             <a:noFill/>
@@ -3914,14 +4010,14 @@
         </p:nvSpPr>
         <p:spPr>
           <a:xfrm>
-            <a:off x="914400" y="1188720"/>
-            <a:ext cx="137160" cy="4389120"/>
+            <a:off x="914400" y="1005840"/>
+            <a:ext cx="137160" cy="4754880"/>
           </a:xfrm>
           <a:prstGeom prst="rect">
             <a:avLst/>
           </a:prstGeom>
           <a:solidFill>
-            <a:srgbClr val="0EA5E9"/>
+            <a:srgbClr val="38BDF8"/>
           </a:solidFill>
           <a:ln>
             <a:noFill/>
@@ -3957,8 +4053,8 @@
         </p:nvSpPr>
         <p:spPr>
           <a:xfrm>
-            <a:off x="1280160" y="1097280"/>
-            <a:ext cx="10058400" cy="4572000"/>
+            <a:off x="1280160" y="914400"/>
+            <a:ext cx="10058400" cy="2743200"/>
           </a:xfrm>
           <a:prstGeom prst="rect">
             <a:avLst/>
@@ -3973,24 +4069,24 @@
           <a:p>
             <a:pPr>
               <a:spcAft>
-                <a:spcPts val="1400"/>
-              </a:spcAft>
-              <a:defRPr sz="1400" b="1">
-                <a:solidFill>
-                  <a:srgbClr val="0EA5E9"/>
-                </a:solidFill>
-                <a:latin typeface="Segoe UI"/>
-              </a:defRPr>
-            </a:pPr>
-            <a:r>
-              <a:t>BUP CSE FEST 2026 HACKATHON · PRELIMINARY ROUND</a:t>
-            </a:r>
-          </a:p>
-          <a:p>
-            <a:pPr>
-              <a:spcAft>
                 <a:spcPts val="1000"/>
               </a:spcAft>
+              <a:defRPr sz="1300" b="1">
+                <a:solidFill>
+                  <a:srgbClr val="38BDF8"/>
+                </a:solidFill>
+                <a:latin typeface="Segoe UI"/>
+              </a:defRPr>
+            </a:pPr>
+            <a:r>
+              <a:t>BUP CSE FEST 2026 HACKATHON · PRELIMINARY ROUND</a:t>
+            </a:r>
+          </a:p>
+          <a:p>
+            <a:pPr>
+              <a:spcAft>
+                <a:spcPts val="800"/>
+              </a:spcAft>
               <a:defRPr sz="4400" b="1">
                 <a:solidFill>
                   <a:srgbClr val="F8FAFC"/>
@@ -4005,9 +4101,9 @@
           <a:p>
             <a:pPr>
               <a:spcAft>
-                <a:spcPts val="3600"/>
+                <a:spcPts val="1800"/>
               </a:spcAft>
-              <a:defRPr sz="1800">
+              <a:defRPr sz="1700">
                 <a:solidFill>
                   <a:srgbClr val="94A3B8"/>
                 </a:solidFill>
@@ -4018,17 +4114,472 @@
               <a:t>Provably Optimal Smart Campus Microgrid Management via Deep LLM Directive Interpretation and SciPy HiGHS Linear Programming</a:t>
             </a:r>
           </a:p>
-          <a:p>
-            <a:pPr>
-              <a:defRPr sz="1400">
-                <a:solidFill>
-                  <a:srgbClr val="10B981"/>
-                </a:solidFill>
-                <a:latin typeface="Segoe UI"/>
-              </a:defRPr>
-            </a:pPr>
-            <a:r>
-              <a:t>Track: Smart Campus Energy Optimization (GridWise LLM)    |    Duration: 3-Minute Defense</a:t>
+        </p:txBody>
+      </p:sp>
+      <p:sp>
+        <p:nvSpPr>
+          <p:cNvPr id="5" name="Rounded Rectangle 4"/>
+          <p:cNvSpPr/>
+          <p:nvPr/>
+        </p:nvSpPr>
+        <p:spPr>
+          <a:xfrm>
+            <a:off x="1280160" y="3931920"/>
+            <a:ext cx="2423160" cy="1554480"/>
+          </a:xfrm>
+          <a:prstGeom prst="roundRect">
+            <a:avLst/>
+          </a:prstGeom>
+          <a:solidFill>
+            <a:srgbClr val="12192A"/>
+          </a:solidFill>
+          <a:ln w="19050">
+            <a:solidFill>
+              <a:srgbClr val="384B70"/>
+            </a:solidFill>
+          </a:ln>
+        </p:spPr>
+        <p:style>
+          <a:lnRef idx="1">
+            <a:schemeClr val="accent1"/>
+          </a:lnRef>
+          <a:fillRef idx="3">
+            <a:schemeClr val="accent1"/>
+          </a:fillRef>
+          <a:effectRef idx="2">
+            <a:schemeClr val="accent1"/>
+          </a:effectRef>
+          <a:fontRef idx="minor">
+            <a:schemeClr val="lt1"/>
+          </a:fontRef>
+        </p:style>
+        <p:txBody>
+          <a:bodyPr rtlCol="0" anchor="ctr"/>
+          <a:lstStyle/>
+          <a:p>
+            <a:pPr algn="ctr"/>
+          </a:p>
+        </p:txBody>
+      </p:sp>
+      <p:sp>
+        <p:nvSpPr>
+          <p:cNvPr id="6" name="TextBox 5"/>
+          <p:cNvSpPr txBox="1"/>
+          <p:nvPr/>
+        </p:nvSpPr>
+        <p:spPr>
+          <a:xfrm>
+            <a:off x="1463040" y="4069080"/>
+            <a:ext cx="2057400" cy="457200"/>
+          </a:xfrm>
+          <a:prstGeom prst="rect">
+            <a:avLst/>
+          </a:prstGeom>
+          <a:noFill/>
+        </p:spPr>
+        <p:txBody>
+          <a:bodyPr wrap="square">
+            <a:spAutoFit/>
+          </a:bodyPr>
+          <a:lstStyle/>
+          <a:p>
+            <a:pPr>
+              <a:defRPr sz="1300" b="1">
+                <a:solidFill>
+                  <a:srgbClr val="38BDF8"/>
+                </a:solidFill>
+                <a:latin typeface="Segoe UI"/>
+              </a:defRPr>
+            </a:pPr>
+            <a:r>
+              <a:t>☀️ Solar PV</a:t>
+            </a:r>
+          </a:p>
+        </p:txBody>
+      </p:sp>
+      <p:sp>
+        <p:nvSpPr>
+          <p:cNvPr id="7" name="TextBox 6"/>
+          <p:cNvSpPr txBox="1"/>
+          <p:nvPr/>
+        </p:nvSpPr>
+        <p:spPr>
+          <a:xfrm>
+            <a:off x="1417320" y="4434840"/>
+            <a:ext cx="2148840" cy="822960"/>
+          </a:xfrm>
+          <a:prstGeom prst="rect">
+            <a:avLst/>
+          </a:prstGeom>
+          <a:noFill/>
+        </p:spPr>
+        <p:txBody>
+          <a:bodyPr wrap="square">
+            <a:spAutoFit/>
+          </a:bodyPr>
+          <a:lstStyle/>
+          <a:p>
+            <a:pPr>
+              <a:defRPr sz="1050">
+                <a:solidFill>
+                  <a:srgbClr val="94A3B8"/>
+                </a:solidFill>
+                <a:latin typeface="Segoe UI"/>
+              </a:defRPr>
+            </a:pPr>
+            <a:r>
+              <a:t>Rooftop generation with dynamic operational curtailment factor.</a:t>
+            </a:r>
+          </a:p>
+        </p:txBody>
+      </p:sp>
+      <p:sp>
+        <p:nvSpPr>
+          <p:cNvPr id="8" name="Rounded Rectangle 7"/>
+          <p:cNvSpPr/>
+          <p:nvPr/>
+        </p:nvSpPr>
+        <p:spPr>
+          <a:xfrm>
+            <a:off x="3922776" y="3931920"/>
+            <a:ext cx="2423160" cy="1554480"/>
+          </a:xfrm>
+          <a:prstGeom prst="roundRect">
+            <a:avLst/>
+          </a:prstGeom>
+          <a:solidFill>
+            <a:srgbClr val="12192A"/>
+          </a:solidFill>
+          <a:ln w="19050">
+            <a:solidFill>
+              <a:srgbClr val="384B70"/>
+            </a:solidFill>
+          </a:ln>
+        </p:spPr>
+        <p:style>
+          <a:lnRef idx="1">
+            <a:schemeClr val="accent1"/>
+          </a:lnRef>
+          <a:fillRef idx="3">
+            <a:schemeClr val="accent1"/>
+          </a:fillRef>
+          <a:effectRef idx="2">
+            <a:schemeClr val="accent1"/>
+          </a:effectRef>
+          <a:fontRef idx="minor">
+            <a:schemeClr val="lt1"/>
+          </a:fontRef>
+        </p:style>
+        <p:txBody>
+          <a:bodyPr rtlCol="0" anchor="ctr"/>
+          <a:lstStyle/>
+          <a:p>
+            <a:pPr algn="ctr"/>
+          </a:p>
+        </p:txBody>
+      </p:sp>
+      <p:sp>
+        <p:nvSpPr>
+          <p:cNvPr id="9" name="TextBox 8"/>
+          <p:cNvSpPr txBox="1"/>
+          <p:nvPr/>
+        </p:nvSpPr>
+        <p:spPr>
+          <a:xfrm>
+            <a:off x="4105656" y="4069080"/>
+            <a:ext cx="2057400" cy="457200"/>
+          </a:xfrm>
+          <a:prstGeom prst="rect">
+            <a:avLst/>
+          </a:prstGeom>
+          <a:noFill/>
+        </p:spPr>
+        <p:txBody>
+          <a:bodyPr wrap="square">
+            <a:spAutoFit/>
+          </a:bodyPr>
+          <a:lstStyle/>
+          <a:p>
+            <a:pPr>
+              <a:defRPr sz="1300" b="1">
+                <a:solidFill>
+                  <a:srgbClr val="38BDF8"/>
+                </a:solidFill>
+                <a:latin typeface="Segoe UI"/>
+              </a:defRPr>
+            </a:pPr>
+            <a:r>
+              <a:t>🔋 BESS Battery</a:t>
+            </a:r>
+          </a:p>
+        </p:txBody>
+      </p:sp>
+      <p:sp>
+        <p:nvSpPr>
+          <p:cNvPr id="10" name="TextBox 9"/>
+          <p:cNvSpPr txBox="1"/>
+          <p:nvPr/>
+        </p:nvSpPr>
+        <p:spPr>
+          <a:xfrm>
+            <a:off x="4059936" y="4434840"/>
+            <a:ext cx="2148840" cy="822960"/>
+          </a:xfrm>
+          <a:prstGeom prst="rect">
+            <a:avLst/>
+          </a:prstGeom>
+          <a:noFill/>
+        </p:spPr>
+        <p:txBody>
+          <a:bodyPr wrap="square">
+            <a:spAutoFit/>
+          </a:bodyPr>
+          <a:lstStyle/>
+          <a:p>
+            <a:pPr>
+              <a:defRPr sz="1050">
+                <a:solidFill>
+                  <a:srgbClr val="94A3B8"/>
+                </a:solidFill>
+                <a:latin typeface="Segoe UI"/>
+              </a:defRPr>
+            </a:pPr>
+            <a:r>
+              <a:t>500 kWh storage strictly adhering to E24 = E0 end-of-day neutrality.</a:t>
+            </a:r>
+          </a:p>
+        </p:txBody>
+      </p:sp>
+      <p:sp>
+        <p:nvSpPr>
+          <p:cNvPr id="11" name="Rounded Rectangle 10"/>
+          <p:cNvSpPr/>
+          <p:nvPr/>
+        </p:nvSpPr>
+        <p:spPr>
+          <a:xfrm>
+            <a:off x="6565392" y="3931920"/>
+            <a:ext cx="2423160" cy="1554480"/>
+          </a:xfrm>
+          <a:prstGeom prst="roundRect">
+            <a:avLst/>
+          </a:prstGeom>
+          <a:solidFill>
+            <a:srgbClr val="12192A"/>
+          </a:solidFill>
+          <a:ln w="19050">
+            <a:solidFill>
+              <a:srgbClr val="384B70"/>
+            </a:solidFill>
+          </a:ln>
+        </p:spPr>
+        <p:style>
+          <a:lnRef idx="1">
+            <a:schemeClr val="accent1"/>
+          </a:lnRef>
+          <a:fillRef idx="3">
+            <a:schemeClr val="accent1"/>
+          </a:fillRef>
+          <a:effectRef idx="2">
+            <a:schemeClr val="accent1"/>
+          </a:effectRef>
+          <a:fontRef idx="minor">
+            <a:schemeClr val="lt1"/>
+          </a:fontRef>
+        </p:style>
+        <p:txBody>
+          <a:bodyPr rtlCol="0" anchor="ctr"/>
+          <a:lstStyle/>
+          <a:p>
+            <a:pPr algn="ctr"/>
+          </a:p>
+        </p:txBody>
+      </p:sp>
+      <p:sp>
+        <p:nvSpPr>
+          <p:cNvPr id="12" name="TextBox 11"/>
+          <p:cNvSpPr txBox="1"/>
+          <p:nvPr/>
+        </p:nvSpPr>
+        <p:spPr>
+          <a:xfrm>
+            <a:off x="6748272" y="4069080"/>
+            <a:ext cx="2057400" cy="457200"/>
+          </a:xfrm>
+          <a:prstGeom prst="rect">
+            <a:avLst/>
+          </a:prstGeom>
+          <a:noFill/>
+        </p:spPr>
+        <p:txBody>
+          <a:bodyPr wrap="square">
+            <a:spAutoFit/>
+          </a:bodyPr>
+          <a:lstStyle/>
+          <a:p>
+            <a:pPr>
+              <a:defRPr sz="1300" b="1">
+                <a:solidFill>
+                  <a:srgbClr val="38BDF8"/>
+                </a:solidFill>
+                <a:latin typeface="Segoe UI"/>
+              </a:defRPr>
+            </a:pPr>
+            <a:r>
+              <a:t>⚡ Dynamic Grid</a:t>
+            </a:r>
+          </a:p>
+        </p:txBody>
+      </p:sp>
+      <p:sp>
+        <p:nvSpPr>
+          <p:cNvPr id="13" name="TextBox 12"/>
+          <p:cNvSpPr txBox="1"/>
+          <p:nvPr/>
+        </p:nvSpPr>
+        <p:spPr>
+          <a:xfrm>
+            <a:off x="6702552" y="4434840"/>
+            <a:ext cx="2148840" cy="822960"/>
+          </a:xfrm>
+          <a:prstGeom prst="rect">
+            <a:avLst/>
+          </a:prstGeom>
+          <a:noFill/>
+        </p:spPr>
+        <p:txBody>
+          <a:bodyPr wrap="square">
+            <a:spAutoFit/>
+          </a:bodyPr>
+          <a:lstStyle/>
+          <a:p>
+            <a:pPr>
+              <a:defRPr sz="1050">
+                <a:solidFill>
+                  <a:srgbClr val="94A3B8"/>
+                </a:solidFill>
+                <a:latin typeface="Segoe UI"/>
+              </a:defRPr>
+            </a:pPr>
+            <a:r>
+              <a:t>Time-of-Use tariffs optimized for peak-valley cost arbitrage.</a:t>
+            </a:r>
+          </a:p>
+        </p:txBody>
+      </p:sp>
+      <p:sp>
+        <p:nvSpPr>
+          <p:cNvPr id="14" name="Rounded Rectangle 13"/>
+          <p:cNvSpPr/>
+          <p:nvPr/>
+        </p:nvSpPr>
+        <p:spPr>
+          <a:xfrm>
+            <a:off x="9208008" y="3931920"/>
+            <a:ext cx="2423160" cy="1554480"/>
+          </a:xfrm>
+          <a:prstGeom prst="roundRect">
+            <a:avLst/>
+          </a:prstGeom>
+          <a:solidFill>
+            <a:srgbClr val="12192A"/>
+          </a:solidFill>
+          <a:ln w="19050">
+            <a:solidFill>
+              <a:srgbClr val="384B70"/>
+            </a:solidFill>
+          </a:ln>
+        </p:spPr>
+        <p:style>
+          <a:lnRef idx="1">
+            <a:schemeClr val="accent1"/>
+          </a:lnRef>
+          <a:fillRef idx="3">
+            <a:schemeClr val="accent1"/>
+          </a:fillRef>
+          <a:effectRef idx="2">
+            <a:schemeClr val="accent1"/>
+          </a:effectRef>
+          <a:fontRef idx="minor">
+            <a:schemeClr val="lt1"/>
+          </a:fontRef>
+        </p:style>
+        <p:txBody>
+          <a:bodyPr rtlCol="0" anchor="ctr"/>
+          <a:lstStyle/>
+          <a:p>
+            <a:pPr algn="ctr"/>
+          </a:p>
+        </p:txBody>
+      </p:sp>
+      <p:sp>
+        <p:nvSpPr>
+          <p:cNvPr id="15" name="TextBox 14"/>
+          <p:cNvSpPr txBox="1"/>
+          <p:nvPr/>
+        </p:nvSpPr>
+        <p:spPr>
+          <a:xfrm>
+            <a:off x="9390888" y="4069080"/>
+            <a:ext cx="2057400" cy="457200"/>
+          </a:xfrm>
+          <a:prstGeom prst="rect">
+            <a:avLst/>
+          </a:prstGeom>
+          <a:noFill/>
+        </p:spPr>
+        <p:txBody>
+          <a:bodyPr wrap="square">
+            <a:spAutoFit/>
+          </a:bodyPr>
+          <a:lstStyle/>
+          <a:p>
+            <a:pPr>
+              <a:defRPr sz="1300" b="1">
+                <a:solidFill>
+                  <a:srgbClr val="38BDF8"/>
+                </a:solidFill>
+                <a:latin typeface="Segoe UI"/>
+              </a:defRPr>
+            </a:pPr>
+            <a:r>
+              <a:t>📝 Directives</a:t>
+            </a:r>
+          </a:p>
+        </p:txBody>
+      </p:sp>
+      <p:sp>
+        <p:nvSpPr>
+          <p:cNvPr id="16" name="TextBox 15"/>
+          <p:cNvSpPr txBox="1"/>
+          <p:nvPr/>
+        </p:nvSpPr>
+        <p:spPr>
+          <a:xfrm>
+            <a:off x="9345168" y="4434840"/>
+            <a:ext cx="2148840" cy="822960"/>
+          </a:xfrm>
+          <a:prstGeom prst="rect">
+            <a:avLst/>
+          </a:prstGeom>
+          <a:noFill/>
+        </p:spPr>
+        <p:txBody>
+          <a:bodyPr wrap="square">
+            <a:spAutoFit/>
+          </a:bodyPr>
+          <a:lstStyle/>
+          <a:p>
+            <a:pPr>
+              <a:defRPr sz="1050">
+                <a:solidFill>
+                  <a:srgbClr val="94A3B8"/>
+                </a:solidFill>
+                <a:latin typeface="Segoe UI"/>
+              </a:defRPr>
+            </a:pPr>
+            <a:r>
+              <a:t>Natural-language operator constraints normalized by guardrails.</a:t>
             </a:r>
           </a:p>
         </p:txBody>
@@ -4066,7 +4617,7 @@
             <a:avLst/>
           </a:prstGeom>
           <a:solidFill>
-            <a:srgbClr val="0F172A"/>
+            <a:srgbClr val="070A12"/>
           </a:solidFill>
           <a:ln>
             <a:noFill/>
@@ -4132,7 +4683,7 @@
             <a:pPr>
               <a:defRPr sz="1400">
                 <a:solidFill>
-                  <a:srgbClr val="0EA5E9"/>
+                  <a:srgbClr val="38BDF8"/>
                 </a:solidFill>
                 <a:latin typeface="Segoe UI"/>
               </a:defRPr>
@@ -4158,11 +4709,11 @@
             <a:avLst/>
           </a:prstGeom>
           <a:solidFill>
-            <a:srgbClr val="1E293B"/>
+            <a:srgbClr val="12192A"/>
           </a:solidFill>
           <a:ln w="19050">
             <a:solidFill>
-              <a:srgbClr val="0EA5E9"/>
+              <a:srgbClr val="38BDF8"/>
             </a:solidFill>
           </a:ln>
         </p:spPr>
@@ -4213,7 +4764,7 @@
             <a:pPr>
               <a:defRPr sz="1100" b="1">
                 <a:solidFill>
-                  <a:srgbClr val="0EA5E9"/>
+                  <a:srgbClr val="38BDF8"/>
                 </a:solidFill>
                 <a:latin typeface="Segoe UI"/>
               </a:defRPr>
@@ -4267,7 +4818,7 @@
               </a:defRPr>
             </a:pPr>
             <a:r>
-              <a:t>• Strict POST /optimize-energy contract</a:t>
+              <a:t>• Strict Section 07 API contracts.</a:t>
             </a:r>
           </a:p>
           <a:p>
@@ -4283,7 +4834,7 @@
               </a:defRPr>
             </a:pPr>
             <a:r>
-              <a:t>• Relational schema validation (E0 &lt;= capacity)</a:t>
+              <a:t>• Relational: E0 &lt;= Capacity, Min Reserve &lt;= Capacity.</a:t>
             </a:r>
           </a:p>
           <a:p>
@@ -4299,7 +4850,7 @@
               </a:defRPr>
             </a:pPr>
             <a:r>
-              <a:t>• Sanitizes NaN, Inf, non-finite floats</a:t>
+              <a:t>• Sanitizes NaN, Inf, non-finite floats.</a:t>
             </a:r>
           </a:p>
           <a:p>
@@ -4315,7 +4866,7 @@
               </a:defRPr>
             </a:pPr>
             <a:r>
-              <a:t>• Fails fast with HTTP 400 on malformed payloads</a:t>
+              <a:t>• Fails fast with structured HTTP 400.</a:t>
             </a:r>
           </a:p>
         </p:txBody>
@@ -4335,11 +4886,11 @@
             <a:avLst/>
           </a:prstGeom>
           <a:solidFill>
-            <a:srgbClr val="1E293B"/>
+            <a:srgbClr val="12192A"/>
           </a:solidFill>
           <a:ln w="19050">
             <a:solidFill>
-              <a:srgbClr val="F59E0B"/>
+              <a:srgbClr val="FBBF24"/>
             </a:solidFill>
           </a:ln>
         </p:spPr>
@@ -4390,7 +4941,7 @@
             <a:pPr>
               <a:defRPr sz="1100" b="1">
                 <a:solidFill>
-                  <a:srgbClr val="F59E0B"/>
+                  <a:srgbClr val="FBBF24"/>
                 </a:solidFill>
                 <a:latin typeface="Segoe UI"/>
               </a:defRPr>
@@ -4428,7 +4979,7 @@
               </a:defRPr>
             </a:pPr>
             <a:r>
-              <a:t>Multi-Provider + Fallback</a:t>
+              <a:t>Multi-Provider Adapter</a:t>
             </a:r>
           </a:p>
           <a:p>
@@ -4444,7 +4995,7 @@
               </a:defRPr>
             </a:pPr>
             <a:r>
-              <a:t>• Zero-shot prompting on DeepSeek-V3 / Groq / OpenAI</a:t>
+              <a:t>• Zero-shot extraction on DeepSeek / Groq / OpenAI.</a:t>
             </a:r>
           </a:p>
           <a:p>
@@ -4460,7 +5011,7 @@
               </a:defRPr>
             </a:pPr>
             <a:r>
-              <a:t>• Direct JSON schema output format</a:t>
+              <a:t>• Discriminates real intent vs operator chatter.</a:t>
             </a:r>
           </a:p>
           <a:p>
@@ -4476,7 +5027,7 @@
               </a:defRPr>
             </a:pPr>
             <a:r>
-              <a:t>• Discriminates operational notes vs distractor chatter</a:t>
+              <a:t>• Built-in offline regex fallback ensures 0% downtime.</a:t>
             </a:r>
           </a:p>
           <a:p>
@@ -4492,7 +5043,7 @@
               </a:defRPr>
             </a:pPr>
             <a:r>
-              <a:t>• Built-in offline regex fallback ensures 0% downtime</a:t>
+              <a:t>• 100% service uptime even without API keys.</a:t>
             </a:r>
           </a:p>
         </p:txBody>
@@ -4512,11 +5063,11 @@
             <a:avLst/>
           </a:prstGeom>
           <a:solidFill>
-            <a:srgbClr val="1E293B"/>
+            <a:srgbClr val="12192A"/>
           </a:solidFill>
           <a:ln w="19050">
             <a:solidFill>
-              <a:srgbClr val="10B981"/>
+              <a:srgbClr val="34D399"/>
             </a:solidFill>
           </a:ln>
         </p:spPr>
@@ -4567,7 +5118,7 @@
             <a:pPr>
               <a:defRPr sz="1100" b="1">
                 <a:solidFill>
-                  <a:srgbClr val="10B981"/>
+                  <a:srgbClr val="34D399"/>
                 </a:solidFill>
                 <a:latin typeface="Segoe UI"/>
               </a:defRPr>
@@ -4637,7 +5188,7 @@
               </a:defRPr>
             </a:pPr>
             <a:r>
-              <a:t>• Hour window normalization ([0..23], ascending)</a:t>
+              <a:t>• Hour normalization ([0..23], ascending).</a:t>
             </a:r>
           </a:p>
           <a:p>
@@ -4653,7 +5204,7 @@
               </a:defRPr>
             </a:pPr>
             <a:r>
-              <a:t>• Disambiguates 'reduced by' vs 'reduced to'</a:t>
+              <a:t>• Disambiguates 'reduced by' vs 'reduced to'.</a:t>
             </a:r>
           </a:p>
           <a:p>
@@ -4669,7 +5220,7 @@
               </a:defRPr>
             </a:pPr>
             <a:r>
-              <a:t>• Converts percentage battery reserves to kWh</a:t>
+              <a:t>• Converts percentage battery reserves to kWh.</a:t>
             </a:r>
           </a:p>
         </p:txBody>
@@ -4689,7 +5240,7 @@
             <a:avLst/>
           </a:prstGeom>
           <a:solidFill>
-            <a:srgbClr val="1E293B"/>
+            <a:srgbClr val="12192A"/>
           </a:solidFill>
           <a:ln w="19050">
             <a:solidFill>
@@ -4798,7 +5349,7 @@
               </a:defRPr>
             </a:pPr>
             <a:r>
-              <a:t>• 96 decision variables, 73 microgrid constraints</a:t>
+              <a:t>• 96 decision variables, 73 microgrid constraints.</a:t>
             </a:r>
           </a:p>
           <a:p>
@@ -4814,7 +5365,7 @@
               </a:defRPr>
             </a:pPr>
             <a:r>
-              <a:t>• Guarantees exact mathematical global minimum</a:t>
+              <a:t>• Guarantees exact mathematical global minimum.</a:t>
             </a:r>
           </a:p>
           <a:p>
@@ -4830,7 +5381,7 @@
               </a:defRPr>
             </a:pPr>
             <a:r>
-              <a:t>• Solves in &lt; 5 milliseconds</a:t>
+              <a:t>• Solves 24-hour horizon in &lt; 5 ms.</a:t>
             </a:r>
           </a:p>
           <a:p>
@@ -4846,7 +5397,7 @@
               </a:defRPr>
             </a:pPr>
             <a:r>
-              <a:t>• Independent physics replay validates all 7 laws</a:t>
+              <a:t>• Independent physics replay validates all 7 laws.</a:t>
             </a:r>
           </a:p>
         </p:txBody>
@@ -4884,7 +5435,7 @@
             <a:avLst/>
           </a:prstGeom>
           <a:solidFill>
-            <a:srgbClr val="0F172A"/>
+            <a:srgbClr val="070A12"/>
           </a:solidFill>
           <a:ln>
             <a:noFill/>
@@ -4950,7 +5501,7 @@
             <a:pPr>
               <a:defRPr sz="1400">
                 <a:solidFill>
-                  <a:srgbClr val="0EA5E9"/>
+                  <a:srgbClr val="38BDF8"/>
                 </a:solidFill>
                 <a:latin typeface="Segoe UI"/>
               </a:defRPr>
@@ -4976,11 +5527,11 @@
             <a:avLst/>
           </a:prstGeom>
           <a:solidFill>
-            <a:srgbClr val="1E293B"/>
+            <a:srgbClr val="12192A"/>
           </a:solidFill>
           <a:ln w="19050">
             <a:solidFill>
-              <a:srgbClr val="10B981"/>
+              <a:srgbClr val="34D399"/>
             </a:solidFill>
           </a:ln>
         </p:spPr>
@@ -5034,7 +5585,7 @@
               </a:spcAft>
               <a:defRPr sz="1700" b="1">
                 <a:solidFill>
-                  <a:srgbClr val="10B981"/>
+                  <a:srgbClr val="34D399"/>
                 </a:solidFill>
                 <a:latin typeface="Segoe UI"/>
               </a:defRPr>
@@ -5128,11 +5679,11 @@
             <a:avLst/>
           </a:prstGeom>
           <a:solidFill>
-            <a:srgbClr val="1E293B"/>
+            <a:srgbClr val="12192A"/>
           </a:solidFill>
           <a:ln w="19050">
             <a:solidFill>
-              <a:srgbClr val="F59E0B"/>
+              <a:srgbClr val="FBBF24"/>
             </a:solidFill>
           </a:ln>
         </p:spPr>
@@ -5186,7 +5737,7 @@
               </a:spcAft>
               <a:defRPr sz="1700" b="1">
                 <a:solidFill>
-                  <a:srgbClr val="F59E0B"/>
+                  <a:srgbClr val="FBBF24"/>
                 </a:solidFill>
                 <a:latin typeface="Segoe UI"/>
               </a:defRPr>
@@ -5280,11 +5831,11 @@
             <a:avLst/>
           </a:prstGeom>
           <a:solidFill>
-            <a:srgbClr val="1E293B"/>
+            <a:srgbClr val="12192A"/>
           </a:solidFill>
           <a:ln w="19050">
             <a:solidFill>
-              <a:srgbClr val="0EA5E9"/>
+              <a:srgbClr val="38BDF8"/>
             </a:solidFill>
           </a:ln>
         </p:spPr>
@@ -5338,7 +5889,7 @@
               </a:spcAft>
               <a:defRPr sz="1700" b="1">
                 <a:solidFill>
-                  <a:srgbClr val="0EA5E9"/>
+                  <a:srgbClr val="38BDF8"/>
                 </a:solidFill>
                 <a:latin typeface="Segoe UI"/>
               </a:defRPr>
@@ -5458,7 +6009,7 @@
             <a:avLst/>
           </a:prstGeom>
           <a:solidFill>
-            <a:srgbClr val="0F172A"/>
+            <a:srgbClr val="070A12"/>
           </a:solidFill>
           <a:ln>
             <a:noFill/>
@@ -5524,7 +6075,7 @@
             <a:pPr>
               <a:defRPr sz="1400">
                 <a:solidFill>
-                  <a:srgbClr val="0EA5E9"/>
+                  <a:srgbClr val="38BDF8"/>
                 </a:solidFill>
                 <a:latin typeface="Segoe UI"/>
               </a:defRPr>
@@ -5550,11 +6101,11 @@
             <a:avLst/>
           </a:prstGeom>
           <a:solidFill>
-            <a:srgbClr val="1E293B"/>
+            <a:srgbClr val="12192A"/>
           </a:solidFill>
           <a:ln w="19050">
             <a:solidFill>
-              <a:srgbClr val="0EA5E9"/>
+              <a:srgbClr val="38BDF8"/>
             </a:solidFill>
           </a:ln>
         </p:spPr>
@@ -5603,9 +6154,9 @@
           <a:lstStyle/>
           <a:p>
             <a:pPr>
-              <a:defRPr sz="1400" b="1">
-                <a:solidFill>
-                  <a:srgbClr val="0EA5E9"/>
+              <a:defRPr sz="1300" b="1">
+                <a:solidFill>
+                  <a:srgbClr val="38BDF8"/>
                 </a:solidFill>
                 <a:latin typeface="Segoe UI"/>
               </a:defRPr>
@@ -5641,7 +6192,7 @@
             <a:pPr>
               <a:defRPr sz="1300" b="1">
                 <a:solidFill>
-                  <a:srgbClr val="10B981"/>
+                  <a:srgbClr val="34D399"/>
                 </a:solidFill>
                 <a:latin typeface="Segoe UI"/>
               </a:defRPr>
@@ -5670,7 +6221,7 @@
             <a:pPr>
               <a:defRPr sz="1300" b="1">
                 <a:solidFill>
-                  <a:srgbClr val="F59E0B"/>
+                  <a:srgbClr val="FBBF24"/>
                 </a:solidFill>
                 <a:latin typeface="Segoe UI"/>
               </a:defRPr>
@@ -5808,11 +6359,11 @@
             <a:avLst/>
           </a:prstGeom>
           <a:solidFill>
-            <a:srgbClr val="1E293B"/>
+            <a:srgbClr val="12192A"/>
           </a:solidFill>
           <a:ln w="19050">
             <a:solidFill>
-              <a:srgbClr val="10B981"/>
+              <a:srgbClr val="34D399"/>
             </a:solidFill>
           </a:ln>
         </p:spPr>
@@ -5861,9 +6412,9 @@
           <a:lstStyle/>
           <a:p>
             <a:pPr>
-              <a:defRPr sz="1400" b="1">
-                <a:solidFill>
-                  <a:srgbClr val="0EA5E9"/>
+              <a:defRPr sz="1300" b="1">
+                <a:solidFill>
+                  <a:srgbClr val="38BDF8"/>
                 </a:solidFill>
                 <a:latin typeface="Segoe UI"/>
               </a:defRPr>
@@ -5899,7 +6450,7 @@
             <a:pPr>
               <a:defRPr sz="1300" b="1">
                 <a:solidFill>
-                  <a:srgbClr val="10B981"/>
+                  <a:srgbClr val="34D399"/>
                 </a:solidFill>
                 <a:latin typeface="Segoe UI"/>
               </a:defRPr>
@@ -5928,7 +6479,7 @@
             <a:pPr>
               <a:defRPr sz="1300" b="1">
                 <a:solidFill>
-                  <a:srgbClr val="10B981"/>
+                  <a:srgbClr val="34D399"/>
                 </a:solidFill>
                 <a:latin typeface="Segoe UI"/>
               </a:defRPr>
@@ -5957,7 +6508,7 @@
             <a:pPr>
               <a:defRPr sz="1300" b="1">
                 <a:solidFill>
-                  <a:srgbClr val="10B981"/>
+                  <a:srgbClr val="34D399"/>
                 </a:solidFill>
                 <a:latin typeface="Segoe UI"/>
               </a:defRPr>
@@ -5986,7 +6537,7 @@
             <a:pPr>
               <a:defRPr sz="1300" b="1">
                 <a:solidFill>
-                  <a:srgbClr val="10B981"/>
+                  <a:srgbClr val="34D399"/>
                 </a:solidFill>
                 <a:latin typeface="Segoe UI"/>
               </a:defRPr>
@@ -6046,7 +6597,7 @@
             <a:avLst/>
           </a:prstGeom>
           <a:solidFill>
-            <a:srgbClr val="0F172A"/>
+            <a:srgbClr val="070A12"/>
           </a:solidFill>
           <a:ln>
             <a:noFill/>
@@ -6112,7 +6663,7 @@
             <a:pPr>
               <a:defRPr sz="1400">
                 <a:solidFill>
-                  <a:srgbClr val="0EA5E9"/>
+                  <a:srgbClr val="38BDF8"/>
                 </a:solidFill>
                 <a:latin typeface="Segoe UI"/>
               </a:defRPr>
@@ -6138,11 +6689,11 @@
             <a:avLst/>
           </a:prstGeom>
           <a:solidFill>
-            <a:srgbClr val="1E293B"/>
+            <a:srgbClr val="12192A"/>
           </a:solidFill>
           <a:ln w="19050">
             <a:solidFill>
-              <a:srgbClr val="10B981"/>
+              <a:srgbClr val="34D399"/>
             </a:solidFill>
           </a:ln>
         </p:spPr>
@@ -6193,7 +6744,7 @@
             <a:pPr algn="ctr">
               <a:defRPr sz="2200" b="1">
                 <a:solidFill>
-                  <a:srgbClr val="10B981"/>
+                  <a:srgbClr val="34D399"/>
                 </a:solidFill>
                 <a:latin typeface="Segoe UI"/>
               </a:defRPr>
@@ -6232,11 +6783,11 @@
             <a:avLst/>
           </a:prstGeom>
           <a:solidFill>
-            <a:srgbClr val="1E293B"/>
+            <a:srgbClr val="12192A"/>
           </a:solidFill>
           <a:ln w="19050">
             <a:solidFill>
-              <a:srgbClr val="0EA5E9"/>
+              <a:srgbClr val="38BDF8"/>
             </a:solidFill>
           </a:ln>
         </p:spPr>
@@ -6287,7 +6838,7 @@
             <a:pPr algn="ctr">
               <a:defRPr sz="2200" b="1">
                 <a:solidFill>
-                  <a:srgbClr val="0EA5E9"/>
+                  <a:srgbClr val="38BDF8"/>
                 </a:solidFill>
                 <a:latin typeface="Segoe UI"/>
               </a:defRPr>
@@ -6326,11 +6877,11 @@
             <a:avLst/>
           </a:prstGeom>
           <a:solidFill>
-            <a:srgbClr val="1E293B"/>
+            <a:srgbClr val="12192A"/>
           </a:solidFill>
           <a:ln w="19050">
             <a:solidFill>
-              <a:srgbClr val="F59E0B"/>
+              <a:srgbClr val="FBBF24"/>
             </a:solidFill>
           </a:ln>
         </p:spPr>
@@ -6381,7 +6932,7 @@
             <a:pPr algn="ctr">
               <a:defRPr sz="2200" b="1">
                 <a:solidFill>
-                  <a:srgbClr val="F59E0B"/>
+                  <a:srgbClr val="FBBF24"/>
                 </a:solidFill>
                 <a:latin typeface="Segoe UI"/>
               </a:defRPr>
@@ -6420,7 +6971,7 @@
             <a:avLst/>
           </a:prstGeom>
           <a:solidFill>
-            <a:srgbClr val="1E293B"/>
+            <a:srgbClr val="12192A"/>
           </a:solidFill>
           <a:ln w="19050">
             <a:solidFill>
@@ -6514,11 +7065,11 @@
             <a:avLst/>
           </a:prstGeom>
           <a:solidFill>
-            <a:srgbClr val="1E293B"/>
+            <a:srgbClr val="12192A"/>
           </a:solidFill>
           <a:ln w="19050">
             <a:solidFill>
-              <a:srgbClr val="334155"/>
+              <a:srgbClr val="384B70"/>
             </a:solidFill>
           </a:ln>
         </p:spPr>
@@ -6567,9 +7118,9 @@
           <a:lstStyle/>
           <a:p>
             <a:pPr>
-              <a:defRPr sz="1400" b="1">
-                <a:solidFill>
-                  <a:srgbClr val="0EA5E9"/>
+              <a:defRPr sz="1300" b="1">
+                <a:solidFill>
+                  <a:srgbClr val="38BDF8"/>
                 </a:solidFill>
                 <a:latin typeface="Segoe UI"/>
               </a:defRPr>
@@ -6608,7 +7159,7 @@
               </a:spcAft>
               <a:defRPr sz="1000" b="1">
                 <a:solidFill>
-                  <a:srgbClr val="0EA5E9"/>
+                  <a:srgbClr val="38BDF8"/>
                 </a:solidFill>
                 <a:latin typeface="Consolas"/>
               </a:defRPr>
@@ -6720,7 +7271,7 @@
               </a:spcAft>
               <a:defRPr sz="950">
                 <a:solidFill>
-                  <a:srgbClr val="F59E0B"/>
+                  <a:srgbClr val="FBBF24"/>
                 </a:solidFill>
                 <a:latin typeface="Consolas"/>
               </a:defRPr>
@@ -6764,7 +7315,7 @@
             <a:avLst/>
           </a:prstGeom>
           <a:solidFill>
-            <a:srgbClr val="0F172A"/>
+            <a:srgbClr val="070A12"/>
           </a:solidFill>
           <a:ln>
             <a:noFill/>
@@ -6830,7 +7381,7 @@
             <a:pPr>
               <a:defRPr sz="1400">
                 <a:solidFill>
-                  <a:srgbClr val="0EA5E9"/>
+                  <a:srgbClr val="38BDF8"/>
                 </a:solidFill>
                 <a:latin typeface="Segoe UI"/>
               </a:defRPr>
@@ -6856,11 +7407,11 @@
             <a:avLst/>
           </a:prstGeom>
           <a:solidFill>
-            <a:srgbClr val="1E293B"/>
+            <a:srgbClr val="12192A"/>
           </a:solidFill>
           <a:ln w="19050">
             <a:solidFill>
-              <a:srgbClr val="10B981"/>
+              <a:srgbClr val="34D399"/>
             </a:solidFill>
           </a:ln>
         </p:spPr>
@@ -6909,9 +7460,9 @@
           <a:lstStyle/>
           <a:p>
             <a:pPr>
-              <a:defRPr sz="1400" b="1">
-                <a:solidFill>
-                  <a:srgbClr val="0EA5E9"/>
+              <a:defRPr sz="1300" b="1">
+                <a:solidFill>
+                  <a:srgbClr val="38BDF8"/>
                 </a:solidFill>
                 <a:latin typeface="Segoe UI"/>
               </a:defRPr>
@@ -6947,7 +7498,7 @@
             <a:pPr>
               <a:defRPr sz="1200" b="1">
                 <a:solidFill>
-                  <a:srgbClr val="10B981"/>
+                  <a:srgbClr val="34D399"/>
                 </a:solidFill>
                 <a:latin typeface="Segoe UI"/>
               </a:defRPr>
@@ -6976,7 +7527,7 @@
             <a:pPr>
               <a:defRPr sz="1200" b="1">
                 <a:solidFill>
-                  <a:srgbClr val="10B981"/>
+                  <a:srgbClr val="34D399"/>
                 </a:solidFill>
                 <a:latin typeface="Segoe UI"/>
               </a:defRPr>
@@ -7005,7 +7556,7 @@
             <a:pPr>
               <a:defRPr sz="1200" b="1">
                 <a:solidFill>
-                  <a:srgbClr val="10B981"/>
+                  <a:srgbClr val="34D399"/>
                 </a:solidFill>
                 <a:latin typeface="Segoe UI"/>
               </a:defRPr>
@@ -7034,7 +7585,7 @@
             <a:pPr>
               <a:defRPr sz="1200" b="1">
                 <a:solidFill>
-                  <a:srgbClr val="10B981"/>
+                  <a:srgbClr val="34D399"/>
                 </a:solidFill>
                 <a:latin typeface="Segoe UI"/>
               </a:defRPr>
@@ -7063,7 +7614,7 @@
             <a:pPr>
               <a:defRPr sz="1200" b="1">
                 <a:solidFill>
-                  <a:srgbClr val="10B981"/>
+                  <a:srgbClr val="34D399"/>
                 </a:solidFill>
                 <a:latin typeface="Segoe UI"/>
               </a:defRPr>
@@ -7105,11 +7656,11 @@
             <a:avLst/>
           </a:prstGeom>
           <a:solidFill>
-            <a:srgbClr val="1E293B"/>
+            <a:srgbClr val="12192A"/>
           </a:solidFill>
           <a:ln w="19050">
             <a:solidFill>
-              <a:srgbClr val="0EA5E9"/>
+              <a:srgbClr val="38BDF8"/>
             </a:solidFill>
           </a:ln>
         </p:spPr>
@@ -7158,9 +7709,9 @@
           <a:lstStyle/>
           <a:p>
             <a:pPr>
-              <a:defRPr sz="1400" b="1">
-                <a:solidFill>
-                  <a:srgbClr val="0EA5E9"/>
+              <a:defRPr sz="1300" b="1">
+                <a:solidFill>
+                  <a:srgbClr val="38BDF8"/>
                 </a:solidFill>
                 <a:latin typeface="Segoe UI"/>
               </a:defRPr>

</xml_diff>